<commit_message>
Paper deck: an LSTM slide after the four steps; the user's son2 edits carried in
- new slide 5, 'Step 2 up close: what is an LSTM?': the three gates as
  valves, the memory update as a leaky integrator whose pole the data sets,
  and the LSTM's size in ICRNNA; speaker note to read from
- from the user's son2: the accuracy-against-SNR slide removed, 'my
  classifier' on slide 2, the 63.21 point dropped from the summary (notes
  updated to match; the summary no longer leaves a gap)
- English study page: an LSTM card, cards renumbered, the removed slide
  kept as a card since Moshe asked about that curve

Co-Authored-By: Claude Opus 5.5 <noreply@anthropic.com>
Claude-Session: https://claude.ai/code/session_01UiTC1BeuJK5BZLbarMcqjw
</commit_message>
<xml_diff>
--- a/deck/moshe_paper_icrnna.pptx
+++ b/deck/moshe_paper_icrnna.pptx
@@ -1297,7 +1297,7 @@
           <a:p>
             <a:r>
               <a:rPr lang="en-US" dirty="0"/>
-              <a:t>To sum up. It is a neural network in four steps, and step two, reading in order, does most of the work. Its 63.24 percent is real: we get 63.21 from the paper alone. And it is about one point better than older models, not a big jump. For us, it is a solid classifier to build on. Thank you. I have more detail on each step if you'd like.</a:t>
+              <a:t>To sum up. It is a neural network in four steps, and step two, reading in order, does most of the work. And it is about one point better than older models, not a big jump. For us, it is a solid classifier to build on. Thank you. I have more detail on each step if you'd like.</a:t>
             </a:r>
             <a:endParaRPr lang="en-US" dirty="0"/>
           </a:p>
@@ -2177,7 +2177,7 @@
           <a:p>
             <a:r>
               <a:rPr lang="en-US" dirty="0"/>
-              <a:t>The paper in one sentence: a neural network looks at 128 samples of a radio signal and says which of 11 modulations sent it. They report 63.24 percent right on this dataset, the best of the twelve models they compare. Our own classifier is built on this design.</a:t>
+              <a:t>The paper in one sentence: a neural network looks at 128 samples of a radio signal and says which of 11 modulations sent it. They report 63.24 percent right on this dataset, the best of the twelve models they compare. My own classifier is built on this design.</a:t>
             </a:r>
             <a:endParaRPr lang="en-US" dirty="0"/>
           </a:p>
@@ -2705,7 +2705,7 @@
           <a:p>
             <a:r>
               <a:rPr lang="en-US" dirty="0"/>
-              <a:t>How was it trained and tested? The dataset is split three ways. 70 percent of it, 154,000 frames with the right answer, to learn from. 15 percent, 33,000 frames, to decide when to stop learning. And the last 15 percent, 33,000 frames, kept aside to test the classifier: they are never used for learning, and every result is counted on them. It stopped by itself after 58 passes over the data, and they did it once.</a:t>
+              <a:t>What is an LSTM? It is the layer in step two. It reads the 64 pieces one at a time and carries a memory of 128 numbers from piece to piece. At every piece, three gates act like valves. The forget gate decides how much of the old memory to keep: zero erases it, one keeps all of it. The input gate decides how much of the new piece to write into the memory. The output gate decides how much of the memory to pass on. Each gate is a small learned layer, set fresh at every piece. In signal-processing terms, the memory update is a leaky integrator whose pole the data sets at every step: near one it holds, near zero it resets. In ICRNNA it reads the frame forwards and backwards, in two layers, and holds 83 percent of the model's numbers. It matters because a modulation is a pattern across symbols, and this is the only step that reads across them.</a:t>
             </a:r>
             <a:endParaRPr lang="en-US" dirty="0"/>
           </a:p>
@@ -2793,7 +2793,7 @@
           <a:p>
             <a:r>
               <a:rPr lang="en-US" dirty="0"/>
-              <a:t>Their main result. ICRNNA is first, at 63.24 percent. The next model is half a point behind. The well-known older ones are two to three points behind.</a:t>
+              <a:t>How was it trained and tested? The dataset is split three ways. 70 percent of it, 154,000 frames with the right answer, to learn from. 15 percent, 33,000 frames, to decide when to stop learning. And the last 15 percent, 33,000 frames, kept aside to test the classifier: they are never used for learning, and every result is counted on them. It stopped by itself after 58 passes over the data, and they did it once.</a:t>
             </a:r>
             <a:endParaRPr lang="en-US" dirty="0"/>
           </a:p>
@@ -2881,7 +2881,7 @@
           <a:p>
             <a:r>
               <a:rPr lang="en-US" dirty="0"/>
-              <a:t>Accuracy against noise. At the noisiest level it is right 9 percent of the time, which is guessing among eleven. It improves quickly between minus 10 and 0 dB, and from 0 dB up it is right about 93 percent of the time.</a:t>
+              <a:t>Their main result. ICRNNA is first, at 63.24 percent. The next model is half a point behind. The well-known older ones are two to three points behind.</a:t>
             </a:r>
             <a:endParaRPr lang="en-US" dirty="0"/>
           </a:p>
@@ -4274,7 +4274,7 @@
                 <a:ea typeface="Calibri" pitchFamily="34" charset="-122"/>
                 <a:cs typeface="Calibri" pitchFamily="34" charset="-120"/>
               </a:rPr>
-              <a:t>Its 63.24% is real: we get 63.21% from the paper alone.</a:t>
+              <a:t>It is about one point better than older models, not a big jump.</a:t>
             </a:r>
             <a:endParaRPr lang="en-US" sz="2700" dirty="0"/>
           </a:p>
@@ -4282,110 +4282,7 @@
       </p:sp>
       <p:sp>
         <p:nvSpPr>
-          <p:cNvPr id="9" name="Shape 7"/>
-          <p:cNvSpPr/>
-          <p:nvPr/>
-        </p:nvSpPr>
-        <p:spPr>
-          <a:xfrm>
-            <a:off x="548640" y="3977640"/>
-            <a:ext cx="640080" cy="640080"/>
-          </a:xfrm>
-          <a:prstGeom prst="ellipse">
-            <a:avLst/>
-          </a:prstGeom>
-          <a:solidFill>
-            <a:srgbClr val="F08A24"/>
-          </a:solidFill>
-          <a:ln w="12700">
-            <a:solidFill>
-              <a:srgbClr val="F08A24"/>
-            </a:solidFill>
-            <a:prstDash val="solid"/>
-          </a:ln>
-        </p:spPr>
-      </p:sp>
-      <p:sp>
-        <p:nvSpPr>
-          <p:cNvPr id="10" name="Text 8"/>
-          <p:cNvSpPr txBox="1"/>
-          <p:nvPr/>
-        </p:nvSpPr>
-        <p:spPr>
-          <a:xfrm>
-            <a:off x="548640" y="3977640"/>
-            <a:ext cx="640080" cy="640080"/>
-          </a:xfrm>
-          <a:prstGeom prst="rect">
-            <a:avLst/>
-          </a:prstGeom>
-          <a:noFill/>
-          <a:ln/>
-        </p:spPr>
-        <p:txBody>
-          <a:bodyPr wrap="square" lIns="0" tIns="0" rIns="0" bIns="0" rtlCol="0" anchor="ctr"/>
-          <a:lstStyle/>
-          <a:p>
-            <a:pPr algn="ctr" indent="0" marL="0">
-              <a:buNone/>
-            </a:pPr>
-            <a:r>
-              <a:rPr lang="en-US" sz="2200" b="1" dirty="0">
-                <a:solidFill>
-                  <a:srgbClr val="FFFFFF"/>
-                </a:solidFill>
-                <a:latin typeface="Calibri" pitchFamily="34" charset="0"/>
-                <a:ea typeface="Calibri" pitchFamily="34" charset="-122"/>
-                <a:cs typeface="Calibri" pitchFamily="34" charset="-120"/>
-              </a:rPr>
-              <a:t>3</a:t>
-            </a:r>
-            <a:endParaRPr lang="en-US" sz="2200" dirty="0"/>
-          </a:p>
-        </p:txBody>
-      </p:sp>
-      <p:sp>
-        <p:nvSpPr>
-          <p:cNvPr id="11" name="Text 9"/>
-          <p:cNvSpPr txBox="1"/>
-          <p:nvPr/>
-        </p:nvSpPr>
-        <p:spPr>
-          <a:xfrm>
-            <a:off x="1463040" y="3886200"/>
-            <a:ext cx="10177272" cy="822960"/>
-          </a:xfrm>
-          <a:prstGeom prst="rect">
-            <a:avLst/>
-          </a:prstGeom>
-          <a:noFill/>
-          <a:ln/>
-        </p:spPr>
-        <p:txBody>
-          <a:bodyPr wrap="square" lIns="0" tIns="0" rIns="0" bIns="0" rtlCol="0" anchor="ctr"/>
-          <a:lstStyle/>
-          <a:p>
-            <a:pPr indent="0" marL="0">
-              <a:buNone/>
-            </a:pPr>
-            <a:r>
-              <a:rPr lang="en-US" sz="2700" dirty="0">
-                <a:solidFill>
-                  <a:srgbClr val="FFFFFF"/>
-                </a:solidFill>
-                <a:latin typeface="Calibri" pitchFamily="34" charset="0"/>
-                <a:ea typeface="Calibri" pitchFamily="34" charset="-122"/>
-                <a:cs typeface="Calibri" pitchFamily="34" charset="-120"/>
-              </a:rPr>
-              <a:t>It is about one point better than older models, not a big jump.</a:t>
-            </a:r>
-            <a:endParaRPr lang="en-US" sz="2700" dirty="0"/>
-          </a:p>
-        </p:txBody>
-      </p:sp>
-      <p:sp>
-        <p:nvSpPr>
-          <p:cNvPr id="12" name="Text 10"/>
+          <p:cNvPr id="9" name="Text 7"/>
           <p:cNvSpPr txBox="1"/>
           <p:nvPr/>
         </p:nvSpPr>
@@ -4438,7 +4335,7 @@
       </p:sp>
       <p:sp>
         <p:nvSpPr>
-          <p:cNvPr id="14" name="Text 11"/>
+          <p:cNvPr id="11" name="Text 8"/>
           <p:cNvSpPr txBox="1"/>
           <p:nvPr/>
         </p:nvSpPr>
@@ -12865,7 +12762,7 @@
                 <a:ea typeface="Calibri" pitchFamily="34" charset="-122"/>
                 <a:cs typeface="Calibri" pitchFamily="34" charset="-120"/>
               </a:rPr>
-              <a:t>our classifier</a:t>
+              <a:t>my classifier</a:t>
             </a:r>
             <a:endParaRPr lang="en-US" sz="5600" dirty="0"/>
           </a:p>
@@ -17006,7 +16903,7 @@
                 <a:ea typeface="Calibri" pitchFamily="34" charset="-122"/>
                 <a:cs typeface="Calibri" pitchFamily="34" charset="-120"/>
               </a:rPr>
-              <a:t>THE PAPER</a:t>
+              <a:t>THE PAPER  ·  THE MODEL</a:t>
             </a:r>
             <a:endParaRPr lang="en-US" sz="1400" dirty="0"/>
           </a:p>
@@ -17045,7 +16942,7 @@
                 <a:ea typeface="Calibri" pitchFamily="34" charset="-122"/>
                 <a:cs typeface="Calibri" pitchFamily="34" charset="-120"/>
               </a:rPr>
-              <a:t>How they trained and tested it</a:t>
+              <a:t>Step 2 up close: what is an LSTM?</a:t>
             </a:r>
             <a:endParaRPr lang="en-US" sz="3400" dirty="0"/>
           </a:p>
@@ -17053,18 +16950,57 @@
       </p:sp>
       <p:sp>
         <p:nvSpPr>
-          <p:cNvPr id="4" name="Shape 2"/>
+          <p:cNvPr id="4" name="Text 2"/>
+          <p:cNvSpPr txBox="1"/>
+          <p:nvPr/>
+        </p:nvSpPr>
+        <p:spPr>
+          <a:xfrm>
+            <a:off x="548640" y="1298448"/>
+            <a:ext cx="11091672" cy="777240"/>
+          </a:xfrm>
+          <a:prstGeom prst="rect">
+            <a:avLst/>
+          </a:prstGeom>
+          <a:noFill/>
+          <a:ln/>
+        </p:spPr>
+        <p:txBody>
+          <a:bodyPr wrap="square" lIns="0" tIns="0" rIns="0" bIns="0" rtlCol="0" anchor="t"/>
+          <a:lstStyle/>
+          <a:p>
+            <a:pPr indent="0" marL="0">
+              <a:buNone/>
+            </a:pPr>
+            <a:r>
+              <a:rPr lang="en-US" sz="2100" dirty="0">
+                <a:solidFill>
+                  <a:srgbClr val="1E293B"/>
+                </a:solidFill>
+                <a:latin typeface="Calibri" pitchFamily="34" charset="0"/>
+                <a:ea typeface="Calibri" pitchFamily="34" charset="-122"/>
+                <a:cs typeface="Calibri" pitchFamily="34" charset="-120"/>
+              </a:rPr>
+              <a:t>It reads the 64 pieces one at a time and carries a memory of 128 numbers from piece to piece. At every piece, three gates act like valves:</a:t>
+            </a:r>
+            <a:endParaRPr lang="en-US" sz="2100" dirty="0"/>
+          </a:p>
+        </p:txBody>
+      </p:sp>
+      <p:sp>
+        <p:nvSpPr>
+          <p:cNvPr id="5" name="Shape 3"/>
           <p:cNvSpPr/>
           <p:nvPr/>
         </p:nvSpPr>
         <p:spPr>
           <a:xfrm>
-            <a:off x="548640" y="1463040"/>
-            <a:ext cx="3520440" cy="2651760"/>
+            <a:off x="548640" y="2240280"/>
+            <a:ext cx="2240280" cy="2240280"/>
           </a:xfrm>
           <a:prstGeom prst="roundRect">
             <a:avLst>
-              <a:gd name="adj" fmla="val 4138"/>
+              <a:gd name="adj" fmla="val 4898"/>
             </a:avLst>
           </a:prstGeom>
           <a:solidFill>
@@ -17080,14 +17016,117 @@
       </p:sp>
       <p:sp>
         <p:nvSpPr>
-          <p:cNvPr id="5" name="Text 3"/>
-          <p:cNvSpPr txBox="1"/>
-          <p:nvPr/>
-        </p:nvSpPr>
-        <p:spPr>
-          <a:xfrm>
-            <a:off x="822960" y="1600200"/>
-            <a:ext cx="3108960" cy="411480"/>
+          <p:cNvPr id="6" name="Shape 4"/>
+          <p:cNvSpPr/>
+          <p:nvPr/>
+        </p:nvSpPr>
+        <p:spPr>
+          <a:xfrm>
+            <a:off x="749808" y="2395728"/>
+            <a:ext cx="457200" cy="457200"/>
+          </a:xfrm>
+          <a:prstGeom prst="ellipse">
+            <a:avLst/>
+          </a:prstGeom>
+          <a:solidFill>
+            <a:srgbClr val="0F1B2D"/>
+          </a:solidFill>
+          <a:ln w="12700">
+            <a:solidFill>
+              <a:srgbClr val="0F1B2D"/>
+            </a:solidFill>
+            <a:prstDash val="solid"/>
+          </a:ln>
+        </p:spPr>
+      </p:sp>
+      <p:sp>
+        <p:nvSpPr>
+          <p:cNvPr id="7" name="Text 5"/>
+          <p:cNvSpPr txBox="1"/>
+          <p:nvPr/>
+        </p:nvSpPr>
+        <p:spPr>
+          <a:xfrm>
+            <a:off x="749808" y="2395728"/>
+            <a:ext cx="457200" cy="457200"/>
+          </a:xfrm>
+          <a:prstGeom prst="rect">
+            <a:avLst/>
+          </a:prstGeom>
+          <a:noFill/>
+          <a:ln/>
+        </p:spPr>
+        <p:txBody>
+          <a:bodyPr wrap="square" lIns="0" tIns="0" rIns="0" bIns="0" rtlCol="0" anchor="ctr"/>
+          <a:lstStyle/>
+          <a:p>
+            <a:pPr algn="ctr" indent="0" marL="0">
+              <a:buNone/>
+            </a:pPr>
+            <a:r>
+              <a:rPr lang="en-US" sz="2200" b="1" dirty="0">
+                <a:solidFill>
+                  <a:srgbClr val="FFFFFF"/>
+                </a:solidFill>
+                <a:latin typeface="Calibri" pitchFamily="34" charset="0"/>
+                <a:ea typeface="Calibri" pitchFamily="34" charset="-122"/>
+                <a:cs typeface="Calibri" pitchFamily="34" charset="-120"/>
+              </a:rPr>
+              <a:t>1</a:t>
+            </a:r>
+            <a:endParaRPr lang="en-US" sz="2200" dirty="0"/>
+          </a:p>
+        </p:txBody>
+      </p:sp>
+      <p:sp>
+        <p:nvSpPr>
+          <p:cNvPr id="8" name="Text 6"/>
+          <p:cNvSpPr txBox="1"/>
+          <p:nvPr/>
+        </p:nvSpPr>
+        <p:spPr>
+          <a:xfrm>
+            <a:off x="1325880" y="2395728"/>
+            <a:ext cx="1325880" cy="457200"/>
+          </a:xfrm>
+          <a:prstGeom prst="rect">
+            <a:avLst/>
+          </a:prstGeom>
+          <a:noFill/>
+          <a:ln/>
+        </p:spPr>
+        <p:txBody>
+          <a:bodyPr wrap="square" lIns="0" tIns="0" rIns="0" bIns="0" rtlCol="0" anchor="ctr"/>
+          <a:lstStyle/>
+          <a:p>
+            <a:pPr indent="0" marL="0">
+              <a:buNone/>
+            </a:pPr>
+            <a:r>
+              <a:rPr lang="en-US" sz="2300" b="1" dirty="0">
+                <a:solidFill>
+                  <a:srgbClr val="1E293B"/>
+                </a:solidFill>
+                <a:latin typeface="Calibri" pitchFamily="34" charset="0"/>
+                <a:ea typeface="Calibri" pitchFamily="34" charset="-122"/>
+                <a:cs typeface="Calibri" pitchFamily="34" charset="-120"/>
+              </a:rPr>
+              <a:t>Keep</a:t>
+            </a:r>
+            <a:endParaRPr lang="en-US" sz="2300" dirty="0"/>
+          </a:p>
+        </p:txBody>
+      </p:sp>
+      <p:sp>
+        <p:nvSpPr>
+          <p:cNvPr id="9" name="Text 7"/>
+          <p:cNvSpPr txBox="1"/>
+          <p:nvPr/>
+        </p:nvSpPr>
+        <p:spPr>
+          <a:xfrm>
+            <a:off x="749808" y="2926080"/>
+            <a:ext cx="1874520" cy="365760"/>
           </a:xfrm>
           <a:prstGeom prst="rect">
             <a:avLst/>
@@ -17103,46 +17142,46 @@
               <a:buNone/>
             </a:pPr>
             <a:r>
-              <a:rPr lang="en-US" sz="1800" b="1" dirty="0">
-                <a:solidFill>
-                  <a:srgbClr val="0F1B2D"/>
-                </a:solidFill>
-                <a:latin typeface="Calibri" pitchFamily="34" charset="0"/>
-                <a:ea typeface="Calibri" pitchFamily="34" charset="-122"/>
-                <a:cs typeface="Calibri" pitchFamily="34" charset="-120"/>
-              </a:rPr>
-              <a:t>70% of the dataset: training</a:t>
-            </a:r>
-            <a:endParaRPr lang="en-US" sz="1800" dirty="0"/>
-          </a:p>
-        </p:txBody>
-      </p:sp>
-      <p:sp>
-        <p:nvSpPr>
-          <p:cNvPr id="6" name="Text 4"/>
-          <p:cNvSpPr txBox="1"/>
-          <p:nvPr/>
-        </p:nvSpPr>
-        <p:spPr>
-          <a:xfrm>
-            <a:off x="822960" y="1920240"/>
-            <a:ext cx="3017520" cy="914400"/>
-          </a:xfrm>
-          <a:prstGeom prst="rect">
-            <a:avLst/>
-          </a:prstGeom>
-          <a:noFill/>
-          <a:ln/>
-        </p:spPr>
-        <p:txBody>
-          <a:bodyPr wrap="square" lIns="0" tIns="0" rIns="0" bIns="0" rtlCol="0" anchor="b"/>
-          <a:lstStyle/>
-          <a:p>
-            <a:pPr algn="l" indent="0" marL="0">
-              <a:buNone/>
-            </a:pPr>
-            <a:r>
-              <a:rPr lang="en-US" sz="5000" b="1" dirty="0">
+              <a:rPr lang="en-US" sz="1500" i="1" dirty="0">
+                <a:solidFill>
+                  <a:srgbClr val="5B6B7F"/>
+                </a:solidFill>
+                <a:latin typeface="Calibri" pitchFamily="34" charset="0"/>
+                <a:ea typeface="Calibri" pitchFamily="34" charset="-122"/>
+                <a:cs typeface="Calibri" pitchFamily="34" charset="-120"/>
+              </a:rPr>
+              <a:t>forget gate</a:t>
+            </a:r>
+            <a:endParaRPr lang="en-US" sz="1500" dirty="0"/>
+          </a:p>
+        </p:txBody>
+      </p:sp>
+      <p:sp>
+        <p:nvSpPr>
+          <p:cNvPr id="10" name="Text 8"/>
+          <p:cNvSpPr txBox="1"/>
+          <p:nvPr/>
+        </p:nvSpPr>
+        <p:spPr>
+          <a:xfrm>
+            <a:off x="749808" y="3291840"/>
+            <a:ext cx="1874520" cy="1097280"/>
+          </a:xfrm>
+          <a:prstGeom prst="rect">
+            <a:avLst/>
+          </a:prstGeom>
+          <a:noFill/>
+          <a:ln/>
+        </p:spPr>
+        <p:txBody>
+          <a:bodyPr wrap="square" lIns="0" tIns="0" rIns="0" bIns="0" rtlCol="0" anchor="t"/>
+          <a:lstStyle/>
+          <a:p>
+            <a:pPr indent="0" marL="0">
+              <a:buNone/>
+            </a:pPr>
+            <a:r>
+              <a:rPr lang="en-US" sz="1700" dirty="0">
                 <a:solidFill>
                   <a:srgbClr val="1E293B"/>
                 </a:solidFill>
@@ -17150,65 +17189,26 @@
                 <a:ea typeface="Calibri" pitchFamily="34" charset="-122"/>
                 <a:cs typeface="Calibri" pitchFamily="34" charset="-120"/>
               </a:rPr>
-              <a:t>154,000</a:t>
-            </a:r>
-            <a:endParaRPr lang="en-US" sz="5000" dirty="0"/>
-          </a:p>
-        </p:txBody>
-      </p:sp>
-      <p:sp>
-        <p:nvSpPr>
-          <p:cNvPr id="7" name="Text 5"/>
-          <p:cNvSpPr txBox="1"/>
-          <p:nvPr/>
-        </p:nvSpPr>
-        <p:spPr>
-          <a:xfrm>
-            <a:off x="822960" y="2880360"/>
-            <a:ext cx="3017520" cy="731520"/>
-          </a:xfrm>
-          <a:prstGeom prst="rect">
-            <a:avLst/>
-          </a:prstGeom>
-          <a:noFill/>
-          <a:ln/>
-        </p:spPr>
-        <p:txBody>
-          <a:bodyPr wrap="square" lIns="0" tIns="0" rIns="0" bIns="0" rtlCol="0" anchor="t"/>
-          <a:lstStyle/>
-          <a:p>
-            <a:pPr algn="l" indent="0" marL="0">
-              <a:buNone/>
-            </a:pPr>
-            <a:r>
-              <a:rPr lang="en-US" sz="1900" dirty="0">
-                <a:solidFill>
-                  <a:srgbClr val="5B6B7F"/>
-                </a:solidFill>
-                <a:latin typeface="Calibri" pitchFamily="34" charset="0"/>
-                <a:ea typeface="Calibri" pitchFamily="34" charset="-122"/>
-                <a:cs typeface="Calibri" pitchFamily="34" charset="-120"/>
-              </a:rPr>
-              <a:t>frames with the right answer: it learns from these</a:t>
-            </a:r>
-            <a:endParaRPr lang="en-US" sz="1900" dirty="0"/>
-          </a:p>
-        </p:txBody>
-      </p:sp>
-      <p:sp>
-        <p:nvSpPr>
-          <p:cNvPr id="8" name="Shape 6"/>
+              <a:t>how much of the old memory to keep: 0 erases it, 1 keeps all of it</a:t>
+            </a:r>
+            <a:endParaRPr lang="en-US" sz="1700" dirty="0"/>
+          </a:p>
+        </p:txBody>
+      </p:sp>
+      <p:sp>
+        <p:nvSpPr>
+          <p:cNvPr id="11" name="Shape 9"/>
           <p:cNvSpPr/>
           <p:nvPr/>
         </p:nvSpPr>
         <p:spPr>
           <a:xfrm>
-            <a:off x="4343400" y="1463040"/>
-            <a:ext cx="3520440" cy="2651760"/>
+            <a:off x="2944368" y="2240280"/>
+            <a:ext cx="2240280" cy="2240280"/>
           </a:xfrm>
           <a:prstGeom prst="roundRect">
             <a:avLst>
-              <a:gd name="adj" fmla="val 4138"/>
+              <a:gd name="adj" fmla="val 4898"/>
             </a:avLst>
           </a:prstGeom>
           <a:solidFill>
@@ -17224,135 +17224,199 @@
       </p:sp>
       <p:sp>
         <p:nvSpPr>
-          <p:cNvPr id="9" name="Text 7"/>
-          <p:cNvSpPr txBox="1"/>
-          <p:nvPr/>
-        </p:nvSpPr>
-        <p:spPr>
-          <a:xfrm>
-            <a:off x="4617720" y="1600200"/>
-            <a:ext cx="3108960" cy="411480"/>
-          </a:xfrm>
-          <a:prstGeom prst="rect">
-            <a:avLst/>
-          </a:prstGeom>
-          <a:noFill/>
-          <a:ln/>
-        </p:spPr>
-        <p:txBody>
-          <a:bodyPr wrap="square" lIns="0" tIns="0" rIns="0" bIns="0" rtlCol="0" anchor="t"/>
-          <a:lstStyle/>
-          <a:p>
-            <a:pPr indent="0" marL="0">
-              <a:buNone/>
-            </a:pPr>
-            <a:r>
-              <a:rPr lang="en-US" sz="1800" b="1" dirty="0">
-                <a:solidFill>
-                  <a:srgbClr val="8FA0B5"/>
-                </a:solidFill>
-                <a:latin typeface="Calibri" pitchFamily="34" charset="0"/>
-                <a:ea typeface="Calibri" pitchFamily="34" charset="-122"/>
-                <a:cs typeface="Calibri" pitchFamily="34" charset="-120"/>
-              </a:rPr>
-              <a:t>15%: validation</a:t>
-            </a:r>
-            <a:endParaRPr lang="en-US" sz="1800" dirty="0"/>
-          </a:p>
-        </p:txBody>
-      </p:sp>
-      <p:sp>
-        <p:nvSpPr>
-          <p:cNvPr id="10" name="Text 8"/>
-          <p:cNvSpPr txBox="1"/>
-          <p:nvPr/>
-        </p:nvSpPr>
-        <p:spPr>
-          <a:xfrm>
-            <a:off x="4617720" y="1920240"/>
-            <a:ext cx="3017520" cy="914400"/>
-          </a:xfrm>
-          <a:prstGeom prst="rect">
-            <a:avLst/>
-          </a:prstGeom>
-          <a:noFill/>
-          <a:ln/>
-        </p:spPr>
-        <p:txBody>
-          <a:bodyPr wrap="square" lIns="0" tIns="0" rIns="0" bIns="0" rtlCol="0" anchor="b"/>
-          <a:lstStyle/>
-          <a:p>
-            <a:pPr algn="l" indent="0" marL="0">
-              <a:buNone/>
-            </a:pPr>
-            <a:r>
-              <a:rPr lang="en-US" sz="5000" b="1" dirty="0">
-                <a:solidFill>
-                  <a:srgbClr val="1E293B"/>
-                </a:solidFill>
-                <a:latin typeface="Calibri" pitchFamily="34" charset="0"/>
-                <a:ea typeface="Calibri" pitchFamily="34" charset="-122"/>
-                <a:cs typeface="Calibri" pitchFamily="34" charset="-120"/>
-              </a:rPr>
-              <a:t>33,000</a:t>
-            </a:r>
-            <a:endParaRPr lang="en-US" sz="5000" dirty="0"/>
-          </a:p>
-        </p:txBody>
-      </p:sp>
-      <p:sp>
-        <p:nvSpPr>
-          <p:cNvPr id="11" name="Text 9"/>
-          <p:cNvSpPr txBox="1"/>
-          <p:nvPr/>
-        </p:nvSpPr>
-        <p:spPr>
-          <a:xfrm>
-            <a:off x="4617720" y="2880360"/>
-            <a:ext cx="3017520" cy="731520"/>
-          </a:xfrm>
-          <a:prstGeom prst="rect">
-            <a:avLst/>
-          </a:prstGeom>
-          <a:noFill/>
-          <a:ln/>
-        </p:spPr>
-        <p:txBody>
-          <a:bodyPr wrap="square" lIns="0" tIns="0" rIns="0" bIns="0" rtlCol="0" anchor="t"/>
-          <a:lstStyle/>
-          <a:p>
-            <a:pPr algn="l" indent="0" marL="0">
-              <a:buNone/>
-            </a:pPr>
-            <a:r>
-              <a:rPr lang="en-US" sz="1900" dirty="0">
-                <a:solidFill>
-                  <a:srgbClr val="5B6B7F"/>
-                </a:solidFill>
-                <a:latin typeface="Calibri" pitchFamily="34" charset="0"/>
-                <a:ea typeface="Calibri" pitchFamily="34" charset="-122"/>
-                <a:cs typeface="Calibri" pitchFamily="34" charset="-120"/>
-              </a:rPr>
-              <a:t>frames to decide when to stop learning</a:t>
-            </a:r>
-            <a:endParaRPr lang="en-US" sz="1900" dirty="0"/>
-          </a:p>
-        </p:txBody>
-      </p:sp>
-      <p:sp>
-        <p:nvSpPr>
           <p:cNvPr id="12" name="Shape 10"/>
           <p:cNvSpPr/>
           <p:nvPr/>
         </p:nvSpPr>
         <p:spPr>
           <a:xfrm>
-            <a:off x="8138160" y="1463040"/>
-            <a:ext cx="3520440" cy="2651760"/>
+            <a:off x="3145536" y="2395728"/>
+            <a:ext cx="457200" cy="457200"/>
+          </a:xfrm>
+          <a:prstGeom prst="ellipse">
+            <a:avLst/>
+          </a:prstGeom>
+          <a:solidFill>
+            <a:srgbClr val="0F1B2D"/>
+          </a:solidFill>
+          <a:ln w="12700">
+            <a:solidFill>
+              <a:srgbClr val="0F1B2D"/>
+            </a:solidFill>
+            <a:prstDash val="solid"/>
+          </a:ln>
+        </p:spPr>
+      </p:sp>
+      <p:sp>
+        <p:nvSpPr>
+          <p:cNvPr id="13" name="Text 11"/>
+          <p:cNvSpPr txBox="1"/>
+          <p:nvPr/>
+        </p:nvSpPr>
+        <p:spPr>
+          <a:xfrm>
+            <a:off x="3145536" y="2395728"/>
+            <a:ext cx="457200" cy="457200"/>
+          </a:xfrm>
+          <a:prstGeom prst="rect">
+            <a:avLst/>
+          </a:prstGeom>
+          <a:noFill/>
+          <a:ln/>
+        </p:spPr>
+        <p:txBody>
+          <a:bodyPr wrap="square" lIns="0" tIns="0" rIns="0" bIns="0" rtlCol="0" anchor="ctr"/>
+          <a:lstStyle/>
+          <a:p>
+            <a:pPr algn="ctr" indent="0" marL="0">
+              <a:buNone/>
+            </a:pPr>
+            <a:r>
+              <a:rPr lang="en-US" sz="2200" b="1" dirty="0">
+                <a:solidFill>
+                  <a:srgbClr val="FFFFFF"/>
+                </a:solidFill>
+                <a:latin typeface="Calibri" pitchFamily="34" charset="0"/>
+                <a:ea typeface="Calibri" pitchFamily="34" charset="-122"/>
+                <a:cs typeface="Calibri" pitchFamily="34" charset="-120"/>
+              </a:rPr>
+              <a:t>2</a:t>
+            </a:r>
+            <a:endParaRPr lang="en-US" sz="2200" dirty="0"/>
+          </a:p>
+        </p:txBody>
+      </p:sp>
+      <p:sp>
+        <p:nvSpPr>
+          <p:cNvPr id="14" name="Text 12"/>
+          <p:cNvSpPr txBox="1"/>
+          <p:nvPr/>
+        </p:nvSpPr>
+        <p:spPr>
+          <a:xfrm>
+            <a:off x="3721608" y="2395728"/>
+            <a:ext cx="1325880" cy="457200"/>
+          </a:xfrm>
+          <a:prstGeom prst="rect">
+            <a:avLst/>
+          </a:prstGeom>
+          <a:noFill/>
+          <a:ln/>
+        </p:spPr>
+        <p:txBody>
+          <a:bodyPr wrap="square" lIns="0" tIns="0" rIns="0" bIns="0" rtlCol="0" anchor="ctr"/>
+          <a:lstStyle/>
+          <a:p>
+            <a:pPr indent="0" marL="0">
+              <a:buNone/>
+            </a:pPr>
+            <a:r>
+              <a:rPr lang="en-US" sz="2300" b="1" dirty="0">
+                <a:solidFill>
+                  <a:srgbClr val="1E293B"/>
+                </a:solidFill>
+                <a:latin typeface="Calibri" pitchFamily="34" charset="0"/>
+                <a:ea typeface="Calibri" pitchFamily="34" charset="-122"/>
+                <a:cs typeface="Calibri" pitchFamily="34" charset="-120"/>
+              </a:rPr>
+              <a:t>Write</a:t>
+            </a:r>
+            <a:endParaRPr lang="en-US" sz="2300" dirty="0"/>
+          </a:p>
+        </p:txBody>
+      </p:sp>
+      <p:sp>
+        <p:nvSpPr>
+          <p:cNvPr id="15" name="Text 13"/>
+          <p:cNvSpPr txBox="1"/>
+          <p:nvPr/>
+        </p:nvSpPr>
+        <p:spPr>
+          <a:xfrm>
+            <a:off x="3145536" y="2926080"/>
+            <a:ext cx="1874520" cy="365760"/>
+          </a:xfrm>
+          <a:prstGeom prst="rect">
+            <a:avLst/>
+          </a:prstGeom>
+          <a:noFill/>
+          <a:ln/>
+        </p:spPr>
+        <p:txBody>
+          <a:bodyPr wrap="square" lIns="0" tIns="0" rIns="0" bIns="0" rtlCol="0" anchor="t"/>
+          <a:lstStyle/>
+          <a:p>
+            <a:pPr indent="0" marL="0">
+              <a:buNone/>
+            </a:pPr>
+            <a:r>
+              <a:rPr lang="en-US" sz="1500" i="1" dirty="0">
+                <a:solidFill>
+                  <a:srgbClr val="5B6B7F"/>
+                </a:solidFill>
+                <a:latin typeface="Calibri" pitchFamily="34" charset="0"/>
+                <a:ea typeface="Calibri" pitchFamily="34" charset="-122"/>
+                <a:cs typeface="Calibri" pitchFamily="34" charset="-120"/>
+              </a:rPr>
+              <a:t>input gate</a:t>
+            </a:r>
+            <a:endParaRPr lang="en-US" sz="1500" dirty="0"/>
+          </a:p>
+        </p:txBody>
+      </p:sp>
+      <p:sp>
+        <p:nvSpPr>
+          <p:cNvPr id="16" name="Text 14"/>
+          <p:cNvSpPr txBox="1"/>
+          <p:nvPr/>
+        </p:nvSpPr>
+        <p:spPr>
+          <a:xfrm>
+            <a:off x="3145536" y="3291840"/>
+            <a:ext cx="1874520" cy="1097280"/>
+          </a:xfrm>
+          <a:prstGeom prst="rect">
+            <a:avLst/>
+          </a:prstGeom>
+          <a:noFill/>
+          <a:ln/>
+        </p:spPr>
+        <p:txBody>
+          <a:bodyPr wrap="square" lIns="0" tIns="0" rIns="0" bIns="0" rtlCol="0" anchor="t"/>
+          <a:lstStyle/>
+          <a:p>
+            <a:pPr indent="0" marL="0">
+              <a:buNone/>
+            </a:pPr>
+            <a:r>
+              <a:rPr lang="en-US" sz="1700" dirty="0">
+                <a:solidFill>
+                  <a:srgbClr val="1E293B"/>
+                </a:solidFill>
+                <a:latin typeface="Calibri" pitchFamily="34" charset="0"/>
+                <a:ea typeface="Calibri" pitchFamily="34" charset="-122"/>
+                <a:cs typeface="Calibri" pitchFamily="34" charset="-120"/>
+              </a:rPr>
+              <a:t>how much of the new piece to add to the memory</a:t>
+            </a:r>
+            <a:endParaRPr lang="en-US" sz="1700" dirty="0"/>
+          </a:p>
+        </p:txBody>
+      </p:sp>
+      <p:sp>
+        <p:nvSpPr>
+          <p:cNvPr id="17" name="Shape 15"/>
+          <p:cNvSpPr/>
+          <p:nvPr/>
+        </p:nvSpPr>
+        <p:spPr>
+          <a:xfrm>
+            <a:off x="5340096" y="2240280"/>
+            <a:ext cx="2240280" cy="2240280"/>
           </a:xfrm>
           <a:prstGeom prst="roundRect">
             <a:avLst>
-              <a:gd name="adj" fmla="val 4138"/>
+              <a:gd name="adj" fmla="val 4898"/>
             </a:avLst>
           </a:prstGeom>
           <a:solidFill>
@@ -17368,14 +17432,117 @@
       </p:sp>
       <p:sp>
         <p:nvSpPr>
-          <p:cNvPr id="13" name="Text 11"/>
-          <p:cNvSpPr txBox="1"/>
-          <p:nvPr/>
-        </p:nvSpPr>
-        <p:spPr>
-          <a:xfrm>
-            <a:off x="8412480" y="1600200"/>
-            <a:ext cx="3108960" cy="411480"/>
+          <p:cNvPr id="18" name="Shape 16"/>
+          <p:cNvSpPr/>
+          <p:nvPr/>
+        </p:nvSpPr>
+        <p:spPr>
+          <a:xfrm>
+            <a:off x="5541264" y="2395728"/>
+            <a:ext cx="457200" cy="457200"/>
+          </a:xfrm>
+          <a:prstGeom prst="ellipse">
+            <a:avLst/>
+          </a:prstGeom>
+          <a:solidFill>
+            <a:srgbClr val="0F1B2D"/>
+          </a:solidFill>
+          <a:ln w="12700">
+            <a:solidFill>
+              <a:srgbClr val="0F1B2D"/>
+            </a:solidFill>
+            <a:prstDash val="solid"/>
+          </a:ln>
+        </p:spPr>
+      </p:sp>
+      <p:sp>
+        <p:nvSpPr>
+          <p:cNvPr id="19" name="Text 17"/>
+          <p:cNvSpPr txBox="1"/>
+          <p:nvPr/>
+        </p:nvSpPr>
+        <p:spPr>
+          <a:xfrm>
+            <a:off x="5541264" y="2395728"/>
+            <a:ext cx="457200" cy="457200"/>
+          </a:xfrm>
+          <a:prstGeom prst="rect">
+            <a:avLst/>
+          </a:prstGeom>
+          <a:noFill/>
+          <a:ln/>
+        </p:spPr>
+        <p:txBody>
+          <a:bodyPr wrap="square" lIns="0" tIns="0" rIns="0" bIns="0" rtlCol="0" anchor="ctr"/>
+          <a:lstStyle/>
+          <a:p>
+            <a:pPr algn="ctr" indent="0" marL="0">
+              <a:buNone/>
+            </a:pPr>
+            <a:r>
+              <a:rPr lang="en-US" sz="2200" b="1" dirty="0">
+                <a:solidFill>
+                  <a:srgbClr val="FFFFFF"/>
+                </a:solidFill>
+                <a:latin typeface="Calibri" pitchFamily="34" charset="0"/>
+                <a:ea typeface="Calibri" pitchFamily="34" charset="-122"/>
+                <a:cs typeface="Calibri" pitchFamily="34" charset="-120"/>
+              </a:rPr>
+              <a:t>3</a:t>
+            </a:r>
+            <a:endParaRPr lang="en-US" sz="2200" dirty="0"/>
+          </a:p>
+        </p:txBody>
+      </p:sp>
+      <p:sp>
+        <p:nvSpPr>
+          <p:cNvPr id="20" name="Text 18"/>
+          <p:cNvSpPr txBox="1"/>
+          <p:nvPr/>
+        </p:nvSpPr>
+        <p:spPr>
+          <a:xfrm>
+            <a:off x="6117336" y="2395728"/>
+            <a:ext cx="1325880" cy="457200"/>
+          </a:xfrm>
+          <a:prstGeom prst="rect">
+            <a:avLst/>
+          </a:prstGeom>
+          <a:noFill/>
+          <a:ln/>
+        </p:spPr>
+        <p:txBody>
+          <a:bodyPr wrap="square" lIns="0" tIns="0" rIns="0" bIns="0" rtlCol="0" anchor="ctr"/>
+          <a:lstStyle/>
+          <a:p>
+            <a:pPr indent="0" marL="0">
+              <a:buNone/>
+            </a:pPr>
+            <a:r>
+              <a:rPr lang="en-US" sz="2300" b="1" dirty="0">
+                <a:solidFill>
+                  <a:srgbClr val="1E293B"/>
+                </a:solidFill>
+                <a:latin typeface="Calibri" pitchFamily="34" charset="0"/>
+                <a:ea typeface="Calibri" pitchFamily="34" charset="-122"/>
+                <a:cs typeface="Calibri" pitchFamily="34" charset="-120"/>
+              </a:rPr>
+              <a:t>Show</a:t>
+            </a:r>
+            <a:endParaRPr lang="en-US" sz="2300" dirty="0"/>
+          </a:p>
+        </p:txBody>
+      </p:sp>
+      <p:sp>
+        <p:nvSpPr>
+          <p:cNvPr id="21" name="Text 19"/>
+          <p:cNvSpPr txBox="1"/>
+          <p:nvPr/>
+        </p:nvSpPr>
+        <p:spPr>
+          <a:xfrm>
+            <a:off x="5541264" y="2926080"/>
+            <a:ext cx="1874520" cy="365760"/>
           </a:xfrm>
           <a:prstGeom prst="rect">
             <a:avLst/>
@@ -17391,7 +17558,112 @@
               <a:buNone/>
             </a:pPr>
             <a:r>
-              <a:rPr lang="en-US" sz="1800" b="1" dirty="0">
+              <a:rPr lang="en-US" sz="1500" i="1" dirty="0">
+                <a:solidFill>
+                  <a:srgbClr val="5B6B7F"/>
+                </a:solidFill>
+                <a:latin typeface="Calibri" pitchFamily="34" charset="0"/>
+                <a:ea typeface="Calibri" pitchFamily="34" charset="-122"/>
+                <a:cs typeface="Calibri" pitchFamily="34" charset="-120"/>
+              </a:rPr>
+              <a:t>output gate</a:t>
+            </a:r>
+            <a:endParaRPr lang="en-US" sz="1500" dirty="0"/>
+          </a:p>
+        </p:txBody>
+      </p:sp>
+      <p:sp>
+        <p:nvSpPr>
+          <p:cNvPr id="22" name="Text 20"/>
+          <p:cNvSpPr txBox="1"/>
+          <p:nvPr/>
+        </p:nvSpPr>
+        <p:spPr>
+          <a:xfrm>
+            <a:off x="5541264" y="3291840"/>
+            <a:ext cx="1874520" cy="1097280"/>
+          </a:xfrm>
+          <a:prstGeom prst="rect">
+            <a:avLst/>
+          </a:prstGeom>
+          <a:noFill/>
+          <a:ln/>
+        </p:spPr>
+        <p:txBody>
+          <a:bodyPr wrap="square" lIns="0" tIns="0" rIns="0" bIns="0" rtlCol="0" anchor="t"/>
+          <a:lstStyle/>
+          <a:p>
+            <a:pPr indent="0" marL="0">
+              <a:buNone/>
+            </a:pPr>
+            <a:r>
+              <a:rPr lang="en-US" sz="1700" dirty="0">
+                <a:solidFill>
+                  <a:srgbClr val="1E293B"/>
+                </a:solidFill>
+                <a:latin typeface="Calibri" pitchFamily="34" charset="0"/>
+                <a:ea typeface="Calibri" pitchFamily="34" charset="-122"/>
+                <a:cs typeface="Calibri" pitchFamily="34" charset="-120"/>
+              </a:rPr>
+              <a:t>how much of the memory to pass on</a:t>
+            </a:r>
+            <a:endParaRPr lang="en-US" sz="1700" dirty="0"/>
+          </a:p>
+        </p:txBody>
+      </p:sp>
+      <p:sp>
+        <p:nvSpPr>
+          <p:cNvPr id="23" name="Shape 21"/>
+          <p:cNvSpPr/>
+          <p:nvPr/>
+        </p:nvSpPr>
+        <p:spPr>
+          <a:xfrm>
+            <a:off x="7735824" y="2240280"/>
+            <a:ext cx="3904488" cy="2240280"/>
+          </a:xfrm>
+          <a:prstGeom prst="roundRect">
+            <a:avLst>
+              <a:gd name="adj" fmla="val 4898"/>
+            </a:avLst>
+          </a:prstGeom>
+          <a:solidFill>
+            <a:srgbClr val="0F1B2D"/>
+          </a:solidFill>
+          <a:ln w="12700">
+            <a:solidFill>
+              <a:srgbClr val="0F1B2D"/>
+            </a:solidFill>
+            <a:prstDash val="solid"/>
+          </a:ln>
+        </p:spPr>
+      </p:sp>
+      <p:sp>
+        <p:nvSpPr>
+          <p:cNvPr id="24" name="Text 22"/>
+          <p:cNvSpPr txBox="1"/>
+          <p:nvPr/>
+        </p:nvSpPr>
+        <p:spPr>
+          <a:xfrm>
+            <a:off x="8010144" y="2377440"/>
+            <a:ext cx="3355848" cy="411480"/>
+          </a:xfrm>
+          <a:prstGeom prst="rect">
+            <a:avLst/>
+          </a:prstGeom>
+          <a:noFill/>
+          <a:ln/>
+        </p:spPr>
+        <p:txBody>
+          <a:bodyPr wrap="square" lIns="0" tIns="0" rIns="0" bIns="0" rtlCol="0" anchor="t"/>
+          <a:lstStyle/>
+          <a:p>
+            <a:pPr indent="0" marL="0">
+              <a:buNone/>
+            </a:pPr>
+            <a:r>
+              <a:rPr lang="en-US" sz="1700" b="1" dirty="0">
                 <a:solidFill>
                   <a:srgbClr val="F08A24"/>
                 </a:solidFill>
@@ -17399,61 +17671,22 @@
                 <a:ea typeface="Calibri" pitchFamily="34" charset="-122"/>
                 <a:cs typeface="Calibri" pitchFamily="34" charset="-120"/>
               </a:rPr>
-              <a:t>15%: testing the classifier</a:t>
-            </a:r>
-            <a:endParaRPr lang="en-US" sz="1800" dirty="0"/>
-          </a:p>
-        </p:txBody>
-      </p:sp>
-      <p:sp>
-        <p:nvSpPr>
-          <p:cNvPr id="14" name="Text 12"/>
-          <p:cNvSpPr txBox="1"/>
-          <p:nvPr/>
-        </p:nvSpPr>
-        <p:spPr>
-          <a:xfrm>
-            <a:off x="8412480" y="1920240"/>
-            <a:ext cx="3017520" cy="914400"/>
-          </a:xfrm>
-          <a:prstGeom prst="rect">
-            <a:avLst/>
-          </a:prstGeom>
-          <a:noFill/>
-          <a:ln/>
-        </p:spPr>
-        <p:txBody>
-          <a:bodyPr wrap="square" lIns="0" tIns="0" rIns="0" bIns="0" rtlCol="0" anchor="b"/>
-          <a:lstStyle/>
-          <a:p>
-            <a:pPr algn="l" indent="0" marL="0">
-              <a:buNone/>
-            </a:pPr>
-            <a:r>
-              <a:rPr lang="en-US" sz="5000" b="1" dirty="0">
-                <a:solidFill>
-                  <a:srgbClr val="1E293B"/>
-                </a:solidFill>
-                <a:latin typeface="Calibri" pitchFamily="34" charset="0"/>
-                <a:ea typeface="Calibri" pitchFamily="34" charset="-122"/>
-                <a:cs typeface="Calibri" pitchFamily="34" charset="-120"/>
-              </a:rPr>
-              <a:t>33,000</a:t>
-            </a:r>
-            <a:endParaRPr lang="en-US" sz="5000" dirty="0"/>
-          </a:p>
-        </p:txBody>
-      </p:sp>
-      <p:sp>
-        <p:nvSpPr>
-          <p:cNvPr id="15" name="Text 13"/>
-          <p:cNvSpPr txBox="1"/>
-          <p:nvPr/>
-        </p:nvSpPr>
-        <p:spPr>
-          <a:xfrm>
-            <a:off x="8412480" y="2880360"/>
-            <a:ext cx="3017520" cy="731520"/>
+              <a:t>Signal-processing view</a:t>
+            </a:r>
+            <a:endParaRPr lang="en-US" sz="1700" dirty="0"/>
+          </a:p>
+        </p:txBody>
+      </p:sp>
+      <p:sp>
+        <p:nvSpPr>
+          <p:cNvPr id="25" name="Text 23"/>
+          <p:cNvSpPr txBox="1"/>
+          <p:nvPr/>
+        </p:nvSpPr>
+        <p:spPr>
+          <a:xfrm>
+            <a:off x="8010144" y="2788920"/>
+            <a:ext cx="3355848" cy="731520"/>
           </a:xfrm>
           <a:prstGeom prst="rect">
             <a:avLst/>
@@ -17465,11 +17698,89 @@
           <a:bodyPr wrap="square" lIns="0" tIns="0" rIns="0" bIns="0" rtlCol="0" anchor="t"/>
           <a:lstStyle/>
           <a:p>
-            <a:pPr algn="l" indent="0" marL="0">
-              <a:buNone/>
-            </a:pPr>
-            <a:r>
-              <a:rPr lang="en-US" sz="1900" dirty="0">
+            <a:pPr indent="0" marL="0">
+              <a:buNone/>
+            </a:pPr>
+            <a:r>
+              <a:rPr lang="en-US" sz="1900" b="1" dirty="0">
+                <a:solidFill>
+                  <a:srgbClr val="FFFFFF"/>
+                </a:solidFill>
+                <a:latin typeface="Calibri" pitchFamily="34" charset="0"/>
+                <a:ea typeface="Calibri" pitchFamily="34" charset="-122"/>
+                <a:cs typeface="Calibri" pitchFamily="34" charset="-120"/>
+              </a:rPr>
+              <a:t>memory(t) = keep × memory(t−1) + write × new</a:t>
+            </a:r>
+            <a:endParaRPr lang="en-US" sz="1900" dirty="0"/>
+          </a:p>
+        </p:txBody>
+      </p:sp>
+      <p:sp>
+        <p:nvSpPr>
+          <p:cNvPr id="26" name="Text 24"/>
+          <p:cNvSpPr txBox="1"/>
+          <p:nvPr/>
+        </p:nvSpPr>
+        <p:spPr>
+          <a:xfrm>
+            <a:off x="8010144" y="3566160"/>
+            <a:ext cx="3355848" cy="822960"/>
+          </a:xfrm>
+          <a:prstGeom prst="rect">
+            <a:avLst/>
+          </a:prstGeom>
+          <a:noFill/>
+          <a:ln/>
+        </p:spPr>
+        <p:txBody>
+          <a:bodyPr wrap="square" lIns="0" tIns="0" rIns="0" bIns="0" rtlCol="0" anchor="t"/>
+          <a:lstStyle/>
+          <a:p>
+            <a:pPr indent="0" marL="0">
+              <a:buNone/>
+            </a:pPr>
+            <a:r>
+              <a:rPr lang="en-US" sz="1600" dirty="0">
+                <a:solidFill>
+                  <a:srgbClr val="C9D3E0"/>
+                </a:solidFill>
+                <a:latin typeface="Calibri" pitchFamily="34" charset="0"/>
+                <a:ea typeface="Calibri" pitchFamily="34" charset="-122"/>
+                <a:cs typeface="Calibri" pitchFamily="34" charset="-120"/>
+              </a:rPr>
+              <a:t>A leaky integrator whose pole the data sets at every step: near 1 it holds, near 0 it resets.</a:t>
+            </a:r>
+            <a:endParaRPr lang="en-US" sz="1600" dirty="0"/>
+          </a:p>
+        </p:txBody>
+      </p:sp>
+      <p:sp>
+        <p:nvSpPr>
+          <p:cNvPr id="27" name="Text 25"/>
+          <p:cNvSpPr txBox="1"/>
+          <p:nvPr/>
+        </p:nvSpPr>
+        <p:spPr>
+          <a:xfrm>
+            <a:off x="548640" y="4663440"/>
+            <a:ext cx="11091672" cy="685800"/>
+          </a:xfrm>
+          <a:prstGeom prst="rect">
+            <a:avLst/>
+          </a:prstGeom>
+          <a:noFill/>
+          <a:ln/>
+        </p:spPr>
+        <p:txBody>
+          <a:bodyPr wrap="square" lIns="0" tIns="0" rIns="0" bIns="0" rtlCol="0" anchor="t"/>
+          <a:lstStyle/>
+          <a:p>
+            <a:pPr indent="0" marL="0">
+              <a:buNone/>
+            </a:pPr>
+            <a:r>
+              <a:rPr lang="en-US" sz="1700" dirty="0">
                 <a:solidFill>
                   <a:srgbClr val="5B6B7F"/>
                 </a:solidFill>
@@ -17477,60 +17788,21 @@
                 <a:ea typeface="Calibri" pitchFamily="34" charset="-122"/>
                 <a:cs typeface="Calibri" pitchFamily="34" charset="-120"/>
               </a:rPr>
-              <a:t>frames kept aside: every result is counted on these</a:t>
-            </a:r>
-            <a:endParaRPr lang="en-US" sz="1900" dirty="0"/>
-          </a:p>
-        </p:txBody>
-      </p:sp>
-      <p:sp>
-        <p:nvSpPr>
-          <p:cNvPr id="16" name="Text 14"/>
-          <p:cNvSpPr txBox="1"/>
-          <p:nvPr/>
-        </p:nvSpPr>
-        <p:spPr>
-          <a:xfrm>
-            <a:off x="548640" y="4389120"/>
-            <a:ext cx="11091672" cy="548640"/>
-          </a:xfrm>
-          <a:prstGeom prst="rect">
-            <a:avLst/>
-          </a:prstGeom>
-          <a:noFill/>
-          <a:ln/>
-        </p:spPr>
-        <p:txBody>
-          <a:bodyPr wrap="square" lIns="0" tIns="0" rIns="0" bIns="0" rtlCol="0" anchor="t"/>
-          <a:lstStyle/>
-          <a:p>
-            <a:pPr indent="0" marL="0">
-              <a:buNone/>
-            </a:pPr>
-            <a:r>
-              <a:rPr lang="en-US" sz="2100" dirty="0">
-                <a:solidFill>
-                  <a:srgbClr val="1E293B"/>
-                </a:solidFill>
-                <a:latin typeface="Calibri" pitchFamily="34" charset="0"/>
-                <a:ea typeface="Calibri" pitchFamily="34" charset="-122"/>
-                <a:cs typeface="Calibri" pitchFamily="34" charset="-120"/>
-              </a:rPr>
-              <a:t>It stopped by itself after 58 passes over the data, when it stopped improving. Done once.</a:t>
-            </a:r>
-            <a:endParaRPr lang="en-US" sz="2100" dirty="0"/>
-          </a:p>
-        </p:txBody>
-      </p:sp>
-      <p:sp>
-        <p:nvSpPr>
-          <p:cNvPr id="17" name="Text 15"/>
-          <p:cNvSpPr txBox="1"/>
-          <p:nvPr/>
-        </p:nvSpPr>
-        <p:spPr>
-          <a:xfrm>
-            <a:off x="548640" y="5257800"/>
+              <a:t>Each gate is a small learned layer giving numbers between 0 and 1. In ICRNNA: read forwards and backwards, 2 layers, 659,456 numbers (83% of the model).</a:t>
+            </a:r>
+            <a:endParaRPr lang="en-US" sz="1700" dirty="0"/>
+          </a:p>
+        </p:txBody>
+      </p:sp>
+      <p:sp>
+        <p:nvSpPr>
+          <p:cNvPr id="28" name="Text 26"/>
+          <p:cNvSpPr txBox="1"/>
+          <p:nvPr/>
+        </p:nvSpPr>
+        <p:spPr>
+          <a:xfrm>
+            <a:off x="548640" y="5440680"/>
             <a:ext cx="11091672" cy="640080"/>
           </a:xfrm>
           <a:prstGeom prst="rect">
@@ -17555,7 +17827,7 @@
                 <a:ea typeface="Calibri" pitchFamily="34" charset="-122"/>
                 <a:cs typeface="Calibri" pitchFamily="34" charset="-120"/>
               </a:rPr>
-              <a:t>The test frames are never used for learning.</a:t>
+              <a:t>It is the only step that reads across symbols, which is where a modulation shows.</a:t>
             </a:r>
             <a:endParaRPr lang="en-US" sz="2400" dirty="0"/>
           </a:p>
@@ -17563,7 +17835,7 @@
       </p:sp>
       <p:sp>
         <p:nvSpPr>
-          <p:cNvPr id="19" name="Text 16"/>
+          <p:cNvPr id="30" name="Text 27"/>
           <p:cNvSpPr txBox="1"/>
           <p:nvPr/>
         </p:nvSpPr>
@@ -17658,7 +17930,7 @@
                 <a:ea typeface="Calibri" pitchFamily="34" charset="-122"/>
                 <a:cs typeface="Calibri" pitchFamily="34" charset="-120"/>
               </a:rPr>
-              <a:t>THE PAPER  ·  TABLE 3</a:t>
+              <a:t>THE PAPER</a:t>
             </a:r>
             <a:endParaRPr lang="en-US" sz="1400" dirty="0"/>
           </a:p>
@@ -17697,37 +17969,492 @@
                 <a:ea typeface="Calibri" pitchFamily="34" charset="-122"/>
                 <a:cs typeface="Calibri" pitchFamily="34" charset="-120"/>
               </a:rPr>
-              <a:t>Their main table: first by half a point</a:t>
+              <a:t>How they trained and tested it</a:t>
             </a:r>
             <a:endParaRPr lang="en-US" sz="3400" dirty="0"/>
           </a:p>
         </p:txBody>
       </p:sp>
-      <p:graphicFrame>
-        <p:nvGraphicFramePr>
-          <p:cNvPr id="4" name="Chart 0" descr=""/>
-          <p:cNvGraphicFramePr/>
-          <p:nvPr/>
-        </p:nvGraphicFramePr>
-        <p:xfrm>
-          <a:off x="548640" y="1325880"/>
-          <a:ext cx="11091672" cy="4343400"/>
-        </p:xfrm>
-        <a:graphic xmlns:a="http://schemas.openxmlformats.org/drawingml/2006/main">
-          <a:graphicData uri="http://schemas.openxmlformats.org/drawingml/2006/chart">
-            <c:chart xmlns:c="http://schemas.openxmlformats.org/drawingml/2006/chart" r:id="rId1"/>
-          </a:graphicData>
-        </a:graphic>
-      </p:graphicFrame>
-      <p:sp>
-        <p:nvSpPr>
-          <p:cNvPr id="5" name="Text 2"/>
-          <p:cNvSpPr txBox="1"/>
-          <p:nvPr/>
-        </p:nvSpPr>
-        <p:spPr>
-          <a:xfrm>
-            <a:off x="548640" y="5760720"/>
+      <p:sp>
+        <p:nvSpPr>
+          <p:cNvPr id="4" name="Shape 2"/>
+          <p:cNvSpPr/>
+          <p:nvPr/>
+        </p:nvSpPr>
+        <p:spPr>
+          <a:xfrm>
+            <a:off x="548640" y="1463040"/>
+            <a:ext cx="3520440" cy="2651760"/>
+          </a:xfrm>
+          <a:prstGeom prst="roundRect">
+            <a:avLst>
+              <a:gd name="adj" fmla="val 4138"/>
+            </a:avLst>
+          </a:prstGeom>
+          <a:solidFill>
+            <a:srgbClr val="EEF2F6"/>
+          </a:solidFill>
+          <a:ln w="12700">
+            <a:solidFill>
+              <a:srgbClr val="EEF2F6"/>
+            </a:solidFill>
+            <a:prstDash val="solid"/>
+          </a:ln>
+        </p:spPr>
+      </p:sp>
+      <p:sp>
+        <p:nvSpPr>
+          <p:cNvPr id="5" name="Text 3"/>
+          <p:cNvSpPr txBox="1"/>
+          <p:nvPr/>
+        </p:nvSpPr>
+        <p:spPr>
+          <a:xfrm>
+            <a:off x="822960" y="1600200"/>
+            <a:ext cx="3108960" cy="411480"/>
+          </a:xfrm>
+          <a:prstGeom prst="rect">
+            <a:avLst/>
+          </a:prstGeom>
+          <a:noFill/>
+          <a:ln/>
+        </p:spPr>
+        <p:txBody>
+          <a:bodyPr wrap="square" lIns="0" tIns="0" rIns="0" bIns="0" rtlCol="0" anchor="t"/>
+          <a:lstStyle/>
+          <a:p>
+            <a:pPr indent="0" marL="0">
+              <a:buNone/>
+            </a:pPr>
+            <a:r>
+              <a:rPr lang="en-US" sz="1800" b="1" dirty="0">
+                <a:solidFill>
+                  <a:srgbClr val="0F1B2D"/>
+                </a:solidFill>
+                <a:latin typeface="Calibri" pitchFamily="34" charset="0"/>
+                <a:ea typeface="Calibri" pitchFamily="34" charset="-122"/>
+                <a:cs typeface="Calibri" pitchFamily="34" charset="-120"/>
+              </a:rPr>
+              <a:t>70% of the dataset: training</a:t>
+            </a:r>
+            <a:endParaRPr lang="en-US" sz="1800" dirty="0"/>
+          </a:p>
+        </p:txBody>
+      </p:sp>
+      <p:sp>
+        <p:nvSpPr>
+          <p:cNvPr id="6" name="Text 4"/>
+          <p:cNvSpPr txBox="1"/>
+          <p:nvPr/>
+        </p:nvSpPr>
+        <p:spPr>
+          <a:xfrm>
+            <a:off x="822960" y="1920240"/>
+            <a:ext cx="3017520" cy="914400"/>
+          </a:xfrm>
+          <a:prstGeom prst="rect">
+            <a:avLst/>
+          </a:prstGeom>
+          <a:noFill/>
+          <a:ln/>
+        </p:spPr>
+        <p:txBody>
+          <a:bodyPr wrap="square" lIns="0" tIns="0" rIns="0" bIns="0" rtlCol="0" anchor="b"/>
+          <a:lstStyle/>
+          <a:p>
+            <a:pPr algn="l" indent="0" marL="0">
+              <a:buNone/>
+            </a:pPr>
+            <a:r>
+              <a:rPr lang="en-US" sz="5000" b="1" dirty="0">
+                <a:solidFill>
+                  <a:srgbClr val="1E293B"/>
+                </a:solidFill>
+                <a:latin typeface="Calibri" pitchFamily="34" charset="0"/>
+                <a:ea typeface="Calibri" pitchFamily="34" charset="-122"/>
+                <a:cs typeface="Calibri" pitchFamily="34" charset="-120"/>
+              </a:rPr>
+              <a:t>154,000</a:t>
+            </a:r>
+            <a:endParaRPr lang="en-US" sz="5000" dirty="0"/>
+          </a:p>
+        </p:txBody>
+      </p:sp>
+      <p:sp>
+        <p:nvSpPr>
+          <p:cNvPr id="7" name="Text 5"/>
+          <p:cNvSpPr txBox="1"/>
+          <p:nvPr/>
+        </p:nvSpPr>
+        <p:spPr>
+          <a:xfrm>
+            <a:off x="822960" y="2880360"/>
+            <a:ext cx="3017520" cy="731520"/>
+          </a:xfrm>
+          <a:prstGeom prst="rect">
+            <a:avLst/>
+          </a:prstGeom>
+          <a:noFill/>
+          <a:ln/>
+        </p:spPr>
+        <p:txBody>
+          <a:bodyPr wrap="square" lIns="0" tIns="0" rIns="0" bIns="0" rtlCol="0" anchor="t"/>
+          <a:lstStyle/>
+          <a:p>
+            <a:pPr algn="l" indent="0" marL="0">
+              <a:buNone/>
+            </a:pPr>
+            <a:r>
+              <a:rPr lang="en-US" sz="1900" dirty="0">
+                <a:solidFill>
+                  <a:srgbClr val="5B6B7F"/>
+                </a:solidFill>
+                <a:latin typeface="Calibri" pitchFamily="34" charset="0"/>
+                <a:ea typeface="Calibri" pitchFamily="34" charset="-122"/>
+                <a:cs typeface="Calibri" pitchFamily="34" charset="-120"/>
+              </a:rPr>
+              <a:t>frames with the right answer: it learns from these</a:t>
+            </a:r>
+            <a:endParaRPr lang="en-US" sz="1900" dirty="0"/>
+          </a:p>
+        </p:txBody>
+      </p:sp>
+      <p:sp>
+        <p:nvSpPr>
+          <p:cNvPr id="8" name="Shape 6"/>
+          <p:cNvSpPr/>
+          <p:nvPr/>
+        </p:nvSpPr>
+        <p:spPr>
+          <a:xfrm>
+            <a:off x="4343400" y="1463040"/>
+            <a:ext cx="3520440" cy="2651760"/>
+          </a:xfrm>
+          <a:prstGeom prst="roundRect">
+            <a:avLst>
+              <a:gd name="adj" fmla="val 4138"/>
+            </a:avLst>
+          </a:prstGeom>
+          <a:solidFill>
+            <a:srgbClr val="EEF2F6"/>
+          </a:solidFill>
+          <a:ln w="12700">
+            <a:solidFill>
+              <a:srgbClr val="EEF2F6"/>
+            </a:solidFill>
+            <a:prstDash val="solid"/>
+          </a:ln>
+        </p:spPr>
+      </p:sp>
+      <p:sp>
+        <p:nvSpPr>
+          <p:cNvPr id="9" name="Text 7"/>
+          <p:cNvSpPr txBox="1"/>
+          <p:nvPr/>
+        </p:nvSpPr>
+        <p:spPr>
+          <a:xfrm>
+            <a:off x="4617720" y="1600200"/>
+            <a:ext cx="3108960" cy="411480"/>
+          </a:xfrm>
+          <a:prstGeom prst="rect">
+            <a:avLst/>
+          </a:prstGeom>
+          <a:noFill/>
+          <a:ln/>
+        </p:spPr>
+        <p:txBody>
+          <a:bodyPr wrap="square" lIns="0" tIns="0" rIns="0" bIns="0" rtlCol="0" anchor="t"/>
+          <a:lstStyle/>
+          <a:p>
+            <a:pPr indent="0" marL="0">
+              <a:buNone/>
+            </a:pPr>
+            <a:r>
+              <a:rPr lang="en-US" sz="1800" b="1" dirty="0">
+                <a:solidFill>
+                  <a:srgbClr val="8FA0B5"/>
+                </a:solidFill>
+                <a:latin typeface="Calibri" pitchFamily="34" charset="0"/>
+                <a:ea typeface="Calibri" pitchFamily="34" charset="-122"/>
+                <a:cs typeface="Calibri" pitchFamily="34" charset="-120"/>
+              </a:rPr>
+              <a:t>15%: validation</a:t>
+            </a:r>
+            <a:endParaRPr lang="en-US" sz="1800" dirty="0"/>
+          </a:p>
+        </p:txBody>
+      </p:sp>
+      <p:sp>
+        <p:nvSpPr>
+          <p:cNvPr id="10" name="Text 8"/>
+          <p:cNvSpPr txBox="1"/>
+          <p:nvPr/>
+        </p:nvSpPr>
+        <p:spPr>
+          <a:xfrm>
+            <a:off x="4617720" y="1920240"/>
+            <a:ext cx="3017520" cy="914400"/>
+          </a:xfrm>
+          <a:prstGeom prst="rect">
+            <a:avLst/>
+          </a:prstGeom>
+          <a:noFill/>
+          <a:ln/>
+        </p:spPr>
+        <p:txBody>
+          <a:bodyPr wrap="square" lIns="0" tIns="0" rIns="0" bIns="0" rtlCol="0" anchor="b"/>
+          <a:lstStyle/>
+          <a:p>
+            <a:pPr algn="l" indent="0" marL="0">
+              <a:buNone/>
+            </a:pPr>
+            <a:r>
+              <a:rPr lang="en-US" sz="5000" b="1" dirty="0">
+                <a:solidFill>
+                  <a:srgbClr val="1E293B"/>
+                </a:solidFill>
+                <a:latin typeface="Calibri" pitchFamily="34" charset="0"/>
+                <a:ea typeface="Calibri" pitchFamily="34" charset="-122"/>
+                <a:cs typeface="Calibri" pitchFamily="34" charset="-120"/>
+              </a:rPr>
+              <a:t>33,000</a:t>
+            </a:r>
+            <a:endParaRPr lang="en-US" sz="5000" dirty="0"/>
+          </a:p>
+        </p:txBody>
+      </p:sp>
+      <p:sp>
+        <p:nvSpPr>
+          <p:cNvPr id="11" name="Text 9"/>
+          <p:cNvSpPr txBox="1"/>
+          <p:nvPr/>
+        </p:nvSpPr>
+        <p:spPr>
+          <a:xfrm>
+            <a:off x="4617720" y="2880360"/>
+            <a:ext cx="3017520" cy="731520"/>
+          </a:xfrm>
+          <a:prstGeom prst="rect">
+            <a:avLst/>
+          </a:prstGeom>
+          <a:noFill/>
+          <a:ln/>
+        </p:spPr>
+        <p:txBody>
+          <a:bodyPr wrap="square" lIns="0" tIns="0" rIns="0" bIns="0" rtlCol="0" anchor="t"/>
+          <a:lstStyle/>
+          <a:p>
+            <a:pPr algn="l" indent="0" marL="0">
+              <a:buNone/>
+            </a:pPr>
+            <a:r>
+              <a:rPr lang="en-US" sz="1900" dirty="0">
+                <a:solidFill>
+                  <a:srgbClr val="5B6B7F"/>
+                </a:solidFill>
+                <a:latin typeface="Calibri" pitchFamily="34" charset="0"/>
+                <a:ea typeface="Calibri" pitchFamily="34" charset="-122"/>
+                <a:cs typeface="Calibri" pitchFamily="34" charset="-120"/>
+              </a:rPr>
+              <a:t>frames to decide when to stop learning</a:t>
+            </a:r>
+            <a:endParaRPr lang="en-US" sz="1900" dirty="0"/>
+          </a:p>
+        </p:txBody>
+      </p:sp>
+      <p:sp>
+        <p:nvSpPr>
+          <p:cNvPr id="12" name="Shape 10"/>
+          <p:cNvSpPr/>
+          <p:nvPr/>
+        </p:nvSpPr>
+        <p:spPr>
+          <a:xfrm>
+            <a:off x="8138160" y="1463040"/>
+            <a:ext cx="3520440" cy="2651760"/>
+          </a:xfrm>
+          <a:prstGeom prst="roundRect">
+            <a:avLst>
+              <a:gd name="adj" fmla="val 4138"/>
+            </a:avLst>
+          </a:prstGeom>
+          <a:solidFill>
+            <a:srgbClr val="EEF2F6"/>
+          </a:solidFill>
+          <a:ln w="12700">
+            <a:solidFill>
+              <a:srgbClr val="EEF2F6"/>
+            </a:solidFill>
+            <a:prstDash val="solid"/>
+          </a:ln>
+        </p:spPr>
+      </p:sp>
+      <p:sp>
+        <p:nvSpPr>
+          <p:cNvPr id="13" name="Text 11"/>
+          <p:cNvSpPr txBox="1"/>
+          <p:nvPr/>
+        </p:nvSpPr>
+        <p:spPr>
+          <a:xfrm>
+            <a:off x="8412480" y="1600200"/>
+            <a:ext cx="3108960" cy="411480"/>
+          </a:xfrm>
+          <a:prstGeom prst="rect">
+            <a:avLst/>
+          </a:prstGeom>
+          <a:noFill/>
+          <a:ln/>
+        </p:spPr>
+        <p:txBody>
+          <a:bodyPr wrap="square" lIns="0" tIns="0" rIns="0" bIns="0" rtlCol="0" anchor="t"/>
+          <a:lstStyle/>
+          <a:p>
+            <a:pPr indent="0" marL="0">
+              <a:buNone/>
+            </a:pPr>
+            <a:r>
+              <a:rPr lang="en-US" sz="1800" b="1" dirty="0">
+                <a:solidFill>
+                  <a:srgbClr val="F08A24"/>
+                </a:solidFill>
+                <a:latin typeface="Calibri" pitchFamily="34" charset="0"/>
+                <a:ea typeface="Calibri" pitchFamily="34" charset="-122"/>
+                <a:cs typeface="Calibri" pitchFamily="34" charset="-120"/>
+              </a:rPr>
+              <a:t>15%: testing the classifier</a:t>
+            </a:r>
+            <a:endParaRPr lang="en-US" sz="1800" dirty="0"/>
+          </a:p>
+        </p:txBody>
+      </p:sp>
+      <p:sp>
+        <p:nvSpPr>
+          <p:cNvPr id="14" name="Text 12"/>
+          <p:cNvSpPr txBox="1"/>
+          <p:nvPr/>
+        </p:nvSpPr>
+        <p:spPr>
+          <a:xfrm>
+            <a:off x="8412480" y="1920240"/>
+            <a:ext cx="3017520" cy="914400"/>
+          </a:xfrm>
+          <a:prstGeom prst="rect">
+            <a:avLst/>
+          </a:prstGeom>
+          <a:noFill/>
+          <a:ln/>
+        </p:spPr>
+        <p:txBody>
+          <a:bodyPr wrap="square" lIns="0" tIns="0" rIns="0" bIns="0" rtlCol="0" anchor="b"/>
+          <a:lstStyle/>
+          <a:p>
+            <a:pPr algn="l" indent="0" marL="0">
+              <a:buNone/>
+            </a:pPr>
+            <a:r>
+              <a:rPr lang="en-US" sz="5000" b="1" dirty="0">
+                <a:solidFill>
+                  <a:srgbClr val="1E293B"/>
+                </a:solidFill>
+                <a:latin typeface="Calibri" pitchFamily="34" charset="0"/>
+                <a:ea typeface="Calibri" pitchFamily="34" charset="-122"/>
+                <a:cs typeface="Calibri" pitchFamily="34" charset="-120"/>
+              </a:rPr>
+              <a:t>33,000</a:t>
+            </a:r>
+            <a:endParaRPr lang="en-US" sz="5000" dirty="0"/>
+          </a:p>
+        </p:txBody>
+      </p:sp>
+      <p:sp>
+        <p:nvSpPr>
+          <p:cNvPr id="15" name="Text 13"/>
+          <p:cNvSpPr txBox="1"/>
+          <p:nvPr/>
+        </p:nvSpPr>
+        <p:spPr>
+          <a:xfrm>
+            <a:off x="8412480" y="2880360"/>
+            <a:ext cx="3017520" cy="731520"/>
+          </a:xfrm>
+          <a:prstGeom prst="rect">
+            <a:avLst/>
+          </a:prstGeom>
+          <a:noFill/>
+          <a:ln/>
+        </p:spPr>
+        <p:txBody>
+          <a:bodyPr wrap="square" lIns="0" tIns="0" rIns="0" bIns="0" rtlCol="0" anchor="t"/>
+          <a:lstStyle/>
+          <a:p>
+            <a:pPr algn="l" indent="0" marL="0">
+              <a:buNone/>
+            </a:pPr>
+            <a:r>
+              <a:rPr lang="en-US" sz="1900" dirty="0">
+                <a:solidFill>
+                  <a:srgbClr val="5B6B7F"/>
+                </a:solidFill>
+                <a:latin typeface="Calibri" pitchFamily="34" charset="0"/>
+                <a:ea typeface="Calibri" pitchFamily="34" charset="-122"/>
+                <a:cs typeface="Calibri" pitchFamily="34" charset="-120"/>
+              </a:rPr>
+              <a:t>frames kept aside: every result is counted on these</a:t>
+            </a:r>
+            <a:endParaRPr lang="en-US" sz="1900" dirty="0"/>
+          </a:p>
+        </p:txBody>
+      </p:sp>
+      <p:sp>
+        <p:nvSpPr>
+          <p:cNvPr id="16" name="Text 14"/>
+          <p:cNvSpPr txBox="1"/>
+          <p:nvPr/>
+        </p:nvSpPr>
+        <p:spPr>
+          <a:xfrm>
+            <a:off x="548640" y="4389120"/>
+            <a:ext cx="11091672" cy="548640"/>
+          </a:xfrm>
+          <a:prstGeom prst="rect">
+            <a:avLst/>
+          </a:prstGeom>
+          <a:noFill/>
+          <a:ln/>
+        </p:spPr>
+        <p:txBody>
+          <a:bodyPr wrap="square" lIns="0" tIns="0" rIns="0" bIns="0" rtlCol="0" anchor="t"/>
+          <a:lstStyle/>
+          <a:p>
+            <a:pPr indent="0" marL="0">
+              <a:buNone/>
+            </a:pPr>
+            <a:r>
+              <a:rPr lang="en-US" sz="2100" dirty="0">
+                <a:solidFill>
+                  <a:srgbClr val="1E293B"/>
+                </a:solidFill>
+                <a:latin typeface="Calibri" pitchFamily="34" charset="0"/>
+                <a:ea typeface="Calibri" pitchFamily="34" charset="-122"/>
+                <a:cs typeface="Calibri" pitchFamily="34" charset="-120"/>
+              </a:rPr>
+              <a:t>It stopped by itself after 58 passes over the data, when it stopped improving. Done once.</a:t>
+            </a:r>
+            <a:endParaRPr lang="en-US" sz="2100" dirty="0"/>
+          </a:p>
+        </p:txBody>
+      </p:sp>
+      <p:sp>
+        <p:nvSpPr>
+          <p:cNvPr id="17" name="Text 15"/>
+          <p:cNvSpPr txBox="1"/>
+          <p:nvPr/>
+        </p:nvSpPr>
+        <p:spPr>
+          <a:xfrm>
+            <a:off x="548640" y="5257800"/>
             <a:ext cx="11091672" cy="640080"/>
           </a:xfrm>
           <a:prstGeom prst="rect">
@@ -17752,7 +18479,7 @@
                 <a:ea typeface="Calibri" pitchFamily="34" charset="-122"/>
                 <a:cs typeface="Calibri" pitchFamily="34" charset="-120"/>
               </a:rPr>
-              <a:t>63.24 vs 62.73: the runner-up is half a point behind.</a:t>
+              <a:t>The test frames are never used for learning.</a:t>
             </a:r>
             <a:endParaRPr lang="en-US" sz="2400" dirty="0"/>
           </a:p>
@@ -17760,7 +18487,7 @@
       </p:sp>
       <p:sp>
         <p:nvSpPr>
-          <p:cNvPr id="7" name="Text 3"/>
+          <p:cNvPr id="19" name="Text 16"/>
           <p:cNvSpPr txBox="1"/>
           <p:nvPr/>
         </p:nvSpPr>
@@ -17855,7 +18582,7 @@
                 <a:ea typeface="Calibri" pitchFamily="34" charset="-122"/>
                 <a:cs typeface="Calibri" pitchFamily="34" charset="-120"/>
               </a:rPr>
-              <a:t>THE PAPER  ·  FIG. 8</a:t>
+              <a:t>THE PAPER  ·  TABLE 3</a:t>
             </a:r>
             <a:endParaRPr lang="en-US" sz="1400" dirty="0"/>
           </a:p>
@@ -17894,36 +18621,28 @@
                 <a:ea typeface="Calibri" pitchFamily="34" charset="-122"/>
                 <a:cs typeface="Calibri" pitchFamily="34" charset="-120"/>
               </a:rPr>
-              <a:t>Accuracy against SNR</a:t>
+              <a:t>Their main table: first by half a point</a:t>
             </a:r>
             <a:endParaRPr lang="en-US" sz="3400" dirty="0"/>
           </a:p>
         </p:txBody>
       </p:sp>
-      <p:pic>
-        <p:nvPicPr>
-          <p:cNvPr id="4" name="Image 0" descr="paper/fig8_accuracy_snr.jpg">    </p:cNvPr>
-          <p:cNvPicPr>
-            <a:picLocks noChangeAspect="1"/>
-          </p:cNvPicPr>
-          <p:nvPr/>
-        </p:nvPicPr>
-        <p:blipFill>
-          <a:blip r:embed="rId1"/>
-          <a:stretch>
-            <a:fillRect/>
-          </a:stretch>
-        </p:blipFill>
-        <p:spPr>
-          <a:xfrm>
-            <a:off x="548640" y="1325880"/>
-            <a:ext cx="6309360" cy="4134834"/>
-          </a:xfrm>
-          <a:prstGeom prst="rect">
-            <a:avLst/>
-          </a:prstGeom>
-        </p:spPr>
-      </p:pic>
+      <p:graphicFrame>
+        <p:nvGraphicFramePr>
+          <p:cNvPr id="4" name="Chart 0" descr=""/>
+          <p:cNvGraphicFramePr/>
+          <p:nvPr/>
+        </p:nvGraphicFramePr>
+        <p:xfrm>
+          <a:off x="548640" y="1325880"/>
+          <a:ext cx="11091672" cy="4343400"/>
+        </p:xfrm>
+        <a:graphic xmlns:a="http://schemas.openxmlformats.org/drawingml/2006/main">
+          <a:graphicData uri="http://schemas.openxmlformats.org/drawingml/2006/chart">
+            <c:chart xmlns:c="http://schemas.openxmlformats.org/drawingml/2006/chart" r:id="rId1"/>
+          </a:graphicData>
+        </a:graphic>
+      </p:graphicFrame>
       <p:sp>
         <p:nvSpPr>
           <p:cNvPr id="5" name="Text 2"/>
@@ -17932,213 +18651,40 @@
         </p:nvSpPr>
         <p:spPr>
           <a:xfrm>
-            <a:off x="548640" y="5486400"/>
-            <a:ext cx="6400800" cy="274320"/>
-          </a:xfrm>
-          <a:prstGeom prst="rect">
-            <a:avLst/>
-          </a:prstGeom>
-          <a:noFill/>
-          <a:ln/>
-        </p:spPr>
-        <p:txBody>
-          <a:bodyPr wrap="square" lIns="0" tIns="0" rIns="0" bIns="0" rtlCol="0" anchor="t"/>
-          <a:lstStyle/>
-          <a:p>
-            <a:pPr indent="0" marL="0">
-              <a:buNone/>
-            </a:pPr>
-            <a:r>
-              <a:rPr lang="en-US" sz="1200" i="1" dirty="0">
-                <a:solidFill>
-                  <a:srgbClr val="5B6B7F"/>
-                </a:solidFill>
-                <a:latin typeface="Calibri" pitchFamily="34" charset="0"/>
-                <a:ea typeface="Calibri" pitchFamily="34" charset="-122"/>
-                <a:cs typeface="Calibri" pitchFamily="34" charset="-120"/>
-              </a:rPr>
-              <a:t>Figure from El-Haryqy et al. 2025 (CC BY-NC 4.0)</a:t>
-            </a:r>
-            <a:endParaRPr lang="en-US" sz="1200" dirty="0"/>
-          </a:p>
-        </p:txBody>
-      </p:sp>
-      <p:sp>
-        <p:nvSpPr>
-          <p:cNvPr id="6" name="Text 3"/>
-          <p:cNvSpPr txBox="1"/>
-          <p:nvPr/>
-        </p:nvSpPr>
-        <p:spPr>
-          <a:xfrm>
-            <a:off x="7406640" y="1554480"/>
-            <a:ext cx="4206240" cy="914400"/>
-          </a:xfrm>
-          <a:prstGeom prst="rect">
-            <a:avLst/>
-          </a:prstGeom>
-          <a:noFill/>
-          <a:ln/>
-        </p:spPr>
-        <p:txBody>
-          <a:bodyPr wrap="square" lIns="0" tIns="0" rIns="0" bIns="0" rtlCol="0" anchor="b"/>
-          <a:lstStyle/>
-          <a:p>
-            <a:pPr algn="l" indent="0" marL="0">
-              <a:buNone/>
-            </a:pPr>
-            <a:r>
-              <a:rPr lang="en-US" sz="6000" b="1" dirty="0">
-                <a:solidFill>
-                  <a:srgbClr val="1E293B"/>
-                </a:solidFill>
-                <a:latin typeface="Calibri" pitchFamily="34" charset="0"/>
-                <a:ea typeface="Calibri" pitchFamily="34" charset="-122"/>
-                <a:cs typeface="Calibri" pitchFamily="34" charset="-120"/>
-              </a:rPr>
-              <a:t>9%</a:t>
-            </a:r>
-            <a:endParaRPr lang="en-US" sz="6000" dirty="0"/>
-          </a:p>
-        </p:txBody>
-      </p:sp>
-      <p:sp>
-        <p:nvSpPr>
-          <p:cNvPr id="7" name="Text 4"/>
-          <p:cNvSpPr txBox="1"/>
-          <p:nvPr/>
-        </p:nvSpPr>
-        <p:spPr>
-          <a:xfrm>
-            <a:off x="7406640" y="2514600"/>
-            <a:ext cx="4206240" cy="731520"/>
-          </a:xfrm>
-          <a:prstGeom prst="rect">
-            <a:avLst/>
-          </a:prstGeom>
-          <a:noFill/>
-          <a:ln/>
-        </p:spPr>
-        <p:txBody>
-          <a:bodyPr wrap="square" lIns="0" tIns="0" rIns="0" bIns="0" rtlCol="0" anchor="t"/>
-          <a:lstStyle/>
-          <a:p>
-            <a:pPr algn="l" indent="0" marL="0">
-              <a:buNone/>
-            </a:pPr>
-            <a:r>
-              <a:rPr lang="en-US" sz="1900" dirty="0">
-                <a:solidFill>
-                  <a:srgbClr val="5B6B7F"/>
-                </a:solidFill>
-                <a:latin typeface="Calibri" pitchFamily="34" charset="0"/>
-                <a:ea typeface="Calibri" pitchFamily="34" charset="-122"/>
-                <a:cs typeface="Calibri" pitchFamily="34" charset="-120"/>
-              </a:rPr>
-              <a:t>at −20 dB: chance</a:t>
-            </a:r>
-            <a:endParaRPr lang="en-US" sz="1900" dirty="0"/>
-          </a:p>
-          <a:p>
-            <a:pPr algn="l" indent="0" marL="0">
-              <a:buNone/>
-            </a:pPr>
-            <a:r>
-              <a:rPr lang="en-US" sz="1900" dirty="0">
-                <a:solidFill>
-                  <a:srgbClr val="5B6B7F"/>
-                </a:solidFill>
-                <a:latin typeface="Calibri" pitchFamily="34" charset="0"/>
-                <a:ea typeface="Calibri" pitchFamily="34" charset="-122"/>
-                <a:cs typeface="Calibri" pitchFamily="34" charset="-120"/>
-              </a:rPr>
-              <a:t>(1 in 11)</a:t>
-            </a:r>
-            <a:endParaRPr lang="en-US" sz="1900" dirty="0"/>
-          </a:p>
-        </p:txBody>
-      </p:sp>
-      <p:sp>
-        <p:nvSpPr>
-          <p:cNvPr id="8" name="Text 5"/>
-          <p:cNvSpPr txBox="1"/>
-          <p:nvPr/>
-        </p:nvSpPr>
-        <p:spPr>
-          <a:xfrm>
-            <a:off x="7406640" y="3429000"/>
-            <a:ext cx="4206240" cy="914400"/>
-          </a:xfrm>
-          <a:prstGeom prst="rect">
-            <a:avLst/>
-          </a:prstGeom>
-          <a:noFill/>
-          <a:ln/>
-        </p:spPr>
-        <p:txBody>
-          <a:bodyPr wrap="square" lIns="0" tIns="0" rIns="0" bIns="0" rtlCol="0" anchor="b"/>
-          <a:lstStyle/>
-          <a:p>
-            <a:pPr algn="l" indent="0" marL="0">
-              <a:buNone/>
-            </a:pPr>
-            <a:r>
-              <a:rPr lang="en-US" sz="6000" b="1" dirty="0">
-                <a:solidFill>
-                  <a:srgbClr val="F08A24"/>
-                </a:solidFill>
-                <a:latin typeface="Calibri" pitchFamily="34" charset="0"/>
-                <a:ea typeface="Calibri" pitchFamily="34" charset="-122"/>
-                <a:cs typeface="Calibri" pitchFamily="34" charset="-120"/>
-              </a:rPr>
-              <a:t>~93%</a:t>
-            </a:r>
-            <a:endParaRPr lang="en-US" sz="6000" dirty="0"/>
-          </a:p>
-        </p:txBody>
-      </p:sp>
-      <p:sp>
-        <p:nvSpPr>
-          <p:cNvPr id="9" name="Text 6"/>
-          <p:cNvSpPr txBox="1"/>
-          <p:nvPr/>
-        </p:nvSpPr>
-        <p:spPr>
-          <a:xfrm>
-            <a:off x="7406640" y="4389120"/>
-            <a:ext cx="4206240" cy="731520"/>
-          </a:xfrm>
-          <a:prstGeom prst="rect">
-            <a:avLst/>
-          </a:prstGeom>
-          <a:noFill/>
-          <a:ln/>
-        </p:spPr>
-        <p:txBody>
-          <a:bodyPr wrap="square" lIns="0" tIns="0" rIns="0" bIns="0" rtlCol="0" anchor="t"/>
-          <a:lstStyle/>
-          <a:p>
-            <a:pPr algn="l" indent="0" marL="0">
-              <a:buNone/>
-            </a:pPr>
-            <a:r>
-              <a:rPr lang="en-US" sz="1900" dirty="0">
-                <a:solidFill>
-                  <a:srgbClr val="5B6B7F"/>
-                </a:solidFill>
-                <a:latin typeface="Calibri" pitchFamily="34" charset="0"/>
-                <a:ea typeface="Calibri" pitchFamily="34" charset="-122"/>
-                <a:cs typeface="Calibri" pitchFamily="34" charset="-120"/>
-              </a:rPr>
-              <a:t>from 0 dB up</a:t>
-            </a:r>
-            <a:endParaRPr lang="en-US" sz="1900" dirty="0"/>
-          </a:p>
-        </p:txBody>
-      </p:sp>
-      <p:sp>
-        <p:nvSpPr>
-          <p:cNvPr id="11" name="Text 7"/>
+            <a:off x="548640" y="5760720"/>
+            <a:ext cx="11091672" cy="640080"/>
+          </a:xfrm>
+          <a:prstGeom prst="rect">
+            <a:avLst/>
+          </a:prstGeom>
+          <a:noFill/>
+          <a:ln/>
+        </p:spPr>
+        <p:txBody>
+          <a:bodyPr wrap="square" lIns="0" tIns="0" rIns="0" bIns="0" rtlCol="0" anchor="ctr"/>
+          <a:lstStyle/>
+          <a:p>
+            <a:pPr indent="0" marL="0">
+              <a:buNone/>
+            </a:pPr>
+            <a:r>
+              <a:rPr lang="en-US" sz="2400" b="1" dirty="0">
+                <a:solidFill>
+                  <a:srgbClr val="0F1B2D"/>
+                </a:solidFill>
+                <a:latin typeface="Calibri" pitchFamily="34" charset="0"/>
+                <a:ea typeface="Calibri" pitchFamily="34" charset="-122"/>
+                <a:cs typeface="Calibri" pitchFamily="34" charset="-120"/>
+              </a:rPr>
+              <a:t>63.24 vs 62.73: the runner-up is half a point behind.</a:t>
+            </a:r>
+            <a:endParaRPr lang="en-US" sz="2400" dirty="0"/>
+          </a:p>
+        </p:txBody>
+      </p:sp>
+      <p:sp>
+        <p:nvSpPr>
+          <p:cNvPr id="7" name="Text 3"/>
           <p:cNvSpPr txBox="1"/>
           <p:nvPr/>
         </p:nvSpPr>

</xml_diff>